<commit_message>
Site updated: 2026-05-21 00:14:03
</commit_message>
<xml_diff>
--- a/assets/2026-05-14-组会.pptx
+++ b/assets/2026-05-14-组会.pptx
@@ -115,7 +115,7 @@
 </p:presentation>
 </file>
 
-<file path=ppt/charts/chart4.xml><?xml version="1.0" encoding="utf-8"?>
+<file path=ppt/charts/chart1.xml><?xml version="1.0" encoding="utf-8"?>
 <c:chartSpace xmlns:c="http://schemas.openxmlformats.org/drawingml/2006/chart" xmlns:a="http://schemas.openxmlformats.org/drawingml/2006/main" xmlns:r="http://schemas.openxmlformats.org/officeDocument/2006/relationships">
   <c:date1904 val="0"/>
   <c:roundedCorners val="1"/>
@@ -485,7 +485,7 @@
 </c:chartSpace>
 </file>
 
-<file path=ppt/charts/chart5.xml><?xml version="1.0" encoding="utf-8"?>
+<file path=ppt/charts/chart2.xml><?xml version="1.0" encoding="utf-8"?>
 <c:chartSpace xmlns:c="http://schemas.openxmlformats.org/drawingml/2006/chart" xmlns:a="http://schemas.openxmlformats.org/drawingml/2006/main" xmlns:r="http://schemas.openxmlformats.org/officeDocument/2006/relationships">
   <c:date1904 val="0"/>
   <c:roundedCorners val="1"/>

</xml_diff>